<commit_message>
Kafka-Appell: Rechtschreib-Check (WhatsApp-Fehlertext, Schnipsel) vorgeschaltet, Folien in 27 pt, Diktat entfernt
Co-Authored-By: Claude Opus 5.5 <noreply@anthropic.com>
Claude-Session: https://claude.ai/code/session_01Kzh1oWiqhC6W8oSNq8mKnj
</commit_message>
<xml_diff>
--- a/Deutsch_11/Kafka_Appell/Whiteboard_Rede_Auftrag_Kriterien.pptx
+++ b/Deutsch_11/Kafka_Appell/Whiteboard_Rede_Auftrag_Kriterien.pptx
@@ -884,7 +884,7 @@
         <p:spPr>
           <a:xfrm>
             <a:off x="0" y="0"/>
-            <a:ext cx="12191695" cy="960120"/>
+            <a:ext cx="12191695" cy="914400"/>
           </a:xfrm>
           <a:prstGeom prst="roundRect">
             <a:avLst/>
@@ -903,8 +903,8 @@
         </p:nvSpPr>
         <p:spPr>
           <a:xfrm>
-            <a:off x="457200" y="109728"/>
-            <a:ext cx="8686800" cy="274320"/>
+            <a:off x="457200" y="0"/>
+            <a:ext cx="9326880" cy="914400"/>
           </a:xfrm>
           <a:prstGeom prst="rect">
             <a:avLst/>
@@ -913,53 +913,14 @@
           <a:ln/>
         </p:spPr>
         <p:txBody>
-          <a:bodyPr wrap="square" lIns="0" tIns="0" rIns="0" bIns="0" rtlCol="0" anchor="t"/>
+          <a:bodyPr wrap="square" lIns="0" tIns="0" rIns="0" bIns="0" rtlCol="0" anchor="ctr"/>
           <a:lstStyle/>
           <a:p>
             <a:pPr indent="0" marL="0">
               <a:buNone/>
             </a:pPr>
             <a:r>
-              <a:rPr lang="en-US" sz="1300" b="1" spc="200" kern="0" dirty="0">
-                <a:solidFill>
-                  <a:srgbClr val="CADCFC"/>
-                </a:solidFill>
-                <a:latin typeface="Calibri" pitchFamily="34" charset="0"/>
-                <a:ea typeface="Calibri" pitchFamily="34" charset="-122"/>
-                <a:cs typeface="Calibri" pitchFamily="34" charset="-120"/>
-              </a:rPr>
-              <a:t>TRANSFER · ALLEIN</a:t>
-            </a:r>
-            <a:endParaRPr lang="en-US" sz="1300" dirty="0"/>
-          </a:p>
-        </p:txBody>
-      </p:sp>
-      <p:sp>
-        <p:nvSpPr>
-          <p:cNvPr id="4" name="Text 2"/>
-          <p:cNvSpPr txBox="1"/>
-          <p:nvPr/>
-        </p:nvSpPr>
-        <p:spPr>
-          <a:xfrm>
-            <a:off x="457200" y="384048"/>
-            <a:ext cx="9418320" cy="530352"/>
-          </a:xfrm>
-          <a:prstGeom prst="rect">
-            <a:avLst/>
-          </a:prstGeom>
-          <a:noFill/>
-          <a:ln/>
-        </p:spPr>
-        <p:txBody>
-          <a:bodyPr wrap="square" lIns="0" tIns="0" rIns="0" bIns="0" rtlCol="0" anchor="t"/>
-          <a:lstStyle/>
-          <a:p>
-            <a:pPr indent="0" marL="0">
-              <a:buNone/>
-            </a:pPr>
-            <a:r>
-              <a:rPr lang="en-US" sz="2700" b="1" dirty="0">
+              <a:rPr lang="en-US" sz="3000" b="1" dirty="0">
                 <a:solidFill>
                   <a:srgbClr val="FFFFFF"/>
                 </a:solidFill>
@@ -967,22 +928,22 @@
                 <a:ea typeface="Cambria" pitchFamily="34" charset="-122"/>
                 <a:cs typeface="Cambria" pitchFamily="34" charset="-120"/>
               </a:rPr>
-              <a:t>Kafkas Rede an den Vater</a:t>
-            </a:r>
-            <a:endParaRPr lang="en-US" sz="2700" dirty="0"/>
-          </a:p>
-        </p:txBody>
-      </p:sp>
-      <p:sp>
-        <p:nvSpPr>
-          <p:cNvPr id="5" name="Shape 3"/>
+              <a:t>Transfer: Kafkas Rede an den Vater</a:t>
+            </a:r>
+            <a:endParaRPr lang="en-US" sz="3000" dirty="0"/>
+          </a:p>
+        </p:txBody>
+      </p:sp>
+      <p:sp>
+        <p:nvSpPr>
+          <p:cNvPr id="4" name="Shape 2"/>
           <p:cNvSpPr/>
           <p:nvPr/>
         </p:nvSpPr>
         <p:spPr>
           <a:xfrm>
-            <a:off x="10058400" y="164592"/>
-            <a:ext cx="1737360" cy="640080"/>
+            <a:off x="9966960" y="137160"/>
+            <a:ext cx="1920240" cy="640080"/>
           </a:xfrm>
           <a:prstGeom prst="roundRect">
             <a:avLst>
@@ -997,14 +958,14 @@
       </p:sp>
       <p:sp>
         <p:nvSpPr>
-          <p:cNvPr id="6" name="Text 4"/>
+          <p:cNvPr id="5" name="Text 3"/>
           <p:cNvSpPr txBox="1"/>
           <p:nvPr/>
         </p:nvSpPr>
         <p:spPr>
           <a:xfrm>
-            <a:off x="10058400" y="164592"/>
-            <a:ext cx="1737360" cy="640080"/>
+            <a:off x="9966960" y="137160"/>
+            <a:ext cx="1920240" cy="640080"/>
           </a:xfrm>
           <a:prstGeom prst="rect">
             <a:avLst/>
@@ -1020,7 +981,7 @@
               <a:buNone/>
             </a:pPr>
             <a:r>
-              <a:rPr lang="en-US" sz="2000" b="1" dirty="0">
+              <a:rPr lang="en-US" sz="2700" b="1" dirty="0">
                 <a:solidFill>
                   <a:srgbClr val="FFFFFF"/>
                 </a:solidFill>
@@ -1028,26 +989,26 @@
                 <a:ea typeface="Calibri" pitchFamily="34" charset="-122"/>
                 <a:cs typeface="Calibri" pitchFamily="34" charset="-120"/>
               </a:rPr>
-              <a:t>15 Min.</a:t>
-            </a:r>
-            <a:endParaRPr lang="en-US" sz="2000" dirty="0"/>
-          </a:p>
-        </p:txBody>
-      </p:sp>
-      <p:sp>
-        <p:nvSpPr>
-          <p:cNvPr id="7" name="Shape 5"/>
+              <a:t>12 Min.</a:t>
+            </a:r>
+            <a:endParaRPr lang="en-US" sz="2700" dirty="0"/>
+          </a:p>
+        </p:txBody>
+      </p:sp>
+      <p:sp>
+        <p:nvSpPr>
+          <p:cNvPr id="6" name="Shape 4"/>
           <p:cNvSpPr/>
           <p:nvPr/>
         </p:nvSpPr>
         <p:spPr>
           <a:xfrm>
-            <a:off x="548640" y="1188720"/>
-            <a:ext cx="11064240" cy="1143000"/>
+            <a:off x="457200" y="1097280"/>
+            <a:ext cx="11247120" cy="1600200"/>
           </a:xfrm>
           <a:prstGeom prst="roundRect">
             <a:avLst>
-              <a:gd name="adj" fmla="val 6400"/>
+              <a:gd name="adj" fmla="val 4571"/>
             </a:avLst>
           </a:prstGeom>
           <a:solidFill>
@@ -1058,14 +1019,14 @@
       </p:sp>
       <p:sp>
         <p:nvSpPr>
-          <p:cNvPr id="8" name="Text 6"/>
+          <p:cNvPr id="7" name="Text 5"/>
           <p:cNvSpPr txBox="1"/>
           <p:nvPr/>
         </p:nvSpPr>
         <p:spPr>
           <a:xfrm>
-            <a:off x="777240" y="1261872"/>
-            <a:ext cx="10607040" cy="777240"/>
+            <a:off x="685800" y="1143000"/>
+            <a:ext cx="10789920" cy="1005840"/>
           </a:xfrm>
           <a:prstGeom prst="rect">
             <a:avLst/>
@@ -1081,7 +1042,7 @@
               <a:buNone/>
             </a:pPr>
             <a:r>
-              <a:rPr lang="en-US" sz="2100" b="1" dirty="0">
+              <a:rPr lang="en-US" sz="2700" b="1" dirty="0">
                 <a:solidFill>
                   <a:srgbClr val="1E2761"/>
                 </a:solidFill>
@@ -1089,22 +1050,22 @@
                 <a:ea typeface="Cambria" pitchFamily="34" charset="-122"/>
                 <a:cs typeface="Cambria" pitchFamily="34" charset="-120"/>
               </a:rPr>
-              <a:t>Max Brods Brief hat gewirkt: Hermann Kafka ist bereit, seinem Sohn zuzuhören. Schreibe die Rede, die Franz jetzt an seinen Vater hält.</a:t>
-            </a:r>
-            <a:endParaRPr lang="en-US" sz="2100" dirty="0"/>
-          </a:p>
-        </p:txBody>
-      </p:sp>
-      <p:sp>
-        <p:nvSpPr>
-          <p:cNvPr id="9" name="Text 7"/>
+              <a:t>Max Brods Brief hat gewirkt: Der Vater hört zu. Schreibe die Rede, die Franz jetzt an ihn hält.</a:t>
+            </a:r>
+            <a:endParaRPr lang="en-US" sz="2700" dirty="0"/>
+          </a:p>
+        </p:txBody>
+      </p:sp>
+      <p:sp>
+        <p:nvSpPr>
+          <p:cNvPr id="8" name="Text 6"/>
           <p:cNvSpPr txBox="1"/>
           <p:nvPr/>
         </p:nvSpPr>
         <p:spPr>
           <a:xfrm>
-            <a:off x="777240" y="1965960"/>
-            <a:ext cx="10607040" cy="320040"/>
+            <a:off x="685800" y="2148840"/>
+            <a:ext cx="10789920" cy="457200"/>
           </a:xfrm>
           <a:prstGeom prst="rect">
             <a:avLst/>
@@ -1120,7 +1081,7 @@
               <a:buNone/>
             </a:pPr>
             <a:r>
-              <a:rPr lang="en-US" sz="1600" i="1" dirty="0">
+              <a:rPr lang="en-US" sz="2700" i="1" dirty="0">
                 <a:solidFill>
                   <a:srgbClr val="5B6B8C"/>
                 </a:solidFill>
@@ -1128,61 +1089,22 @@
                 <a:ea typeface="Calibri" pitchFamily="34" charset="-122"/>
                 <a:cs typeface="Calibri" pitchFamily="34" charset="-120"/>
               </a:rPr>
-              <a:t>8–10 Sätze · allein · in den Hefter</a:t>
-            </a:r>
-            <a:endParaRPr lang="en-US" sz="1600" dirty="0"/>
-          </a:p>
-        </p:txBody>
-      </p:sp>
-      <p:sp>
-        <p:nvSpPr>
-          <p:cNvPr id="10" name="Text 8"/>
-          <p:cNvSpPr txBox="1"/>
-          <p:nvPr/>
-        </p:nvSpPr>
-        <p:spPr>
-          <a:xfrm>
-            <a:off x="548640" y="2514600"/>
-            <a:ext cx="7315200" cy="411480"/>
-          </a:xfrm>
-          <a:prstGeom prst="rect">
-            <a:avLst/>
-          </a:prstGeom>
-          <a:noFill/>
-          <a:ln/>
-        </p:spPr>
-        <p:txBody>
-          <a:bodyPr wrap="square" lIns="0" tIns="0" rIns="0" bIns="0" rtlCol="0" anchor="t"/>
-          <a:lstStyle/>
-          <a:p>
-            <a:pPr indent="0" marL="0">
-              <a:buNone/>
-            </a:pPr>
-            <a:r>
-              <a:rPr lang="en-US" sz="2000" b="1" dirty="0">
-                <a:solidFill>
-                  <a:srgbClr val="D9534F"/>
-                </a:solidFill>
-                <a:latin typeface="Cambria" pitchFamily="34" charset="0"/>
-                <a:ea typeface="Cambria" pitchFamily="34" charset="-122"/>
-                <a:cs typeface="Cambria" pitchFamily="34" charset="-120"/>
-              </a:rPr>
-              <a:t>Deine Rede muss enthalten:</a:t>
-            </a:r>
-            <a:endParaRPr lang="en-US" sz="2000" dirty="0"/>
-          </a:p>
-        </p:txBody>
-      </p:sp>
-      <p:sp>
-        <p:nvSpPr>
-          <p:cNvPr id="11" name="Shape 9"/>
+              <a:t>6–8 Sätze · allein · in den Hefter</a:t>
+            </a:r>
+            <a:endParaRPr lang="en-US" sz="2700" dirty="0"/>
+          </a:p>
+        </p:txBody>
+      </p:sp>
+      <p:sp>
+        <p:nvSpPr>
+          <p:cNvPr id="9" name="Shape 7"/>
           <p:cNvSpPr/>
           <p:nvPr/>
         </p:nvSpPr>
         <p:spPr>
           <a:xfrm>
-            <a:off x="548640" y="3017520"/>
-            <a:ext cx="548640" cy="548640"/>
+            <a:off x="457200" y="2880360"/>
+            <a:ext cx="603504" cy="603504"/>
           </a:xfrm>
           <a:prstGeom prst="roundRect">
             <a:avLst>
@@ -1197,14 +1119,14 @@
       </p:sp>
       <p:sp>
         <p:nvSpPr>
-          <p:cNvPr id="12" name="Text 10"/>
+          <p:cNvPr id="10" name="Text 8"/>
           <p:cNvSpPr txBox="1"/>
           <p:nvPr/>
         </p:nvSpPr>
         <p:spPr>
           <a:xfrm>
-            <a:off x="548640" y="3017520"/>
-            <a:ext cx="548640" cy="548640"/>
+            <a:off x="457200" y="2880360"/>
+            <a:ext cx="603504" cy="603504"/>
           </a:xfrm>
           <a:prstGeom prst="rect">
             <a:avLst/>
@@ -1220,7 +1142,7 @@
               <a:buNone/>
             </a:pPr>
             <a:r>
-              <a:rPr lang="en-US" sz="2000" b="1" dirty="0">
+              <a:rPr lang="en-US" sz="2700" b="1" dirty="0">
                 <a:solidFill>
                   <a:srgbClr val="FFFFFF"/>
                 </a:solidFill>
@@ -1230,20 +1152,20 @@
               </a:rPr>
               <a:t>1</a:t>
             </a:r>
-            <a:endParaRPr lang="en-US" sz="2000" dirty="0"/>
-          </a:p>
-        </p:txBody>
-      </p:sp>
-      <p:sp>
-        <p:nvSpPr>
-          <p:cNvPr id="13" name="Text 11"/>
+            <a:endParaRPr lang="en-US" sz="2700" dirty="0"/>
+          </a:p>
+        </p:txBody>
+      </p:sp>
+      <p:sp>
+        <p:nvSpPr>
+          <p:cNvPr id="11" name="Text 9"/>
           <p:cNvSpPr txBox="1"/>
           <p:nvPr/>
         </p:nvSpPr>
         <p:spPr>
           <a:xfrm>
-            <a:off x="1280160" y="3017520"/>
-            <a:ext cx="10332720" cy="548640"/>
+            <a:off x="1280160" y="2880360"/>
+            <a:ext cx="10424160" cy="603504"/>
           </a:xfrm>
           <a:prstGeom prst="rect">
             <a:avLst/>
@@ -1259,7 +1181,7 @@
               <a:buNone/>
             </a:pPr>
             <a:r>
-              <a:rPr lang="en-US" sz="1900" b="1" dirty="0">
+              <a:rPr lang="en-US" sz="2700" b="1" dirty="0">
                 <a:solidFill>
                   <a:srgbClr val="1E2761"/>
                 </a:solidFill>
@@ -1273,7 +1195,7 @@
               <a:buNone/>
             </a:pPr>
             <a:r>
-              <a:rPr lang="en-US" sz="1900" dirty="0">
+              <a:rPr lang="en-US" sz="2700" dirty="0">
                 <a:solidFill>
                   <a:srgbClr val="1E2761"/>
                 </a:solidFill>
@@ -1281,22 +1203,22 @@
                 <a:ea typeface="Calibri" pitchFamily="34" charset="-122"/>
                 <a:cs typeface="Calibri" pitchFamily="34" charset="-120"/>
               </a:rPr>
-              <a:t>Franz spricht den Vater direkt an („Vater, …“).</a:t>
-            </a:r>
-            <a:endParaRPr lang="en-US" sz="1900" dirty="0"/>
-          </a:p>
-        </p:txBody>
-      </p:sp>
-      <p:sp>
-        <p:nvSpPr>
-          <p:cNvPr id="14" name="Shape 12"/>
+              <a:t>„Vater, …“</a:t>
+            </a:r>
+            <a:endParaRPr lang="en-US" sz="2700" dirty="0"/>
+          </a:p>
+        </p:txBody>
+      </p:sp>
+      <p:sp>
+        <p:nvSpPr>
+          <p:cNvPr id="12" name="Shape 10"/>
           <p:cNvSpPr/>
           <p:nvPr/>
         </p:nvSpPr>
         <p:spPr>
           <a:xfrm>
-            <a:off x="548640" y="3703320"/>
-            <a:ext cx="548640" cy="548640"/>
+            <a:off x="457200" y="3648456"/>
+            <a:ext cx="603504" cy="603504"/>
           </a:xfrm>
           <a:prstGeom prst="roundRect">
             <a:avLst>
@@ -1311,14 +1233,14 @@
       </p:sp>
       <p:sp>
         <p:nvSpPr>
-          <p:cNvPr id="15" name="Text 13"/>
+          <p:cNvPr id="13" name="Text 11"/>
           <p:cNvSpPr txBox="1"/>
           <p:nvPr/>
         </p:nvSpPr>
         <p:spPr>
           <a:xfrm>
-            <a:off x="548640" y="3703320"/>
-            <a:ext cx="548640" cy="548640"/>
+            <a:off x="457200" y="3648456"/>
+            <a:ext cx="603504" cy="603504"/>
           </a:xfrm>
           <a:prstGeom prst="rect">
             <a:avLst/>
@@ -1334,7 +1256,7 @@
               <a:buNone/>
             </a:pPr>
             <a:r>
-              <a:rPr lang="en-US" sz="2000" b="1" dirty="0">
+              <a:rPr lang="en-US" sz="2700" b="1" dirty="0">
                 <a:solidFill>
                   <a:srgbClr val="FFFFFF"/>
                 </a:solidFill>
@@ -1344,20 +1266,20 @@
               </a:rPr>
               <a:t>2</a:t>
             </a:r>
-            <a:endParaRPr lang="en-US" sz="2000" dirty="0"/>
-          </a:p>
-        </p:txBody>
-      </p:sp>
-      <p:sp>
-        <p:nvSpPr>
-          <p:cNvPr id="16" name="Text 14"/>
+            <a:endParaRPr lang="en-US" sz="2700" dirty="0"/>
+          </a:p>
+        </p:txBody>
+      </p:sp>
+      <p:sp>
+        <p:nvSpPr>
+          <p:cNvPr id="14" name="Text 12"/>
           <p:cNvSpPr txBox="1"/>
           <p:nvPr/>
         </p:nvSpPr>
         <p:spPr>
           <a:xfrm>
-            <a:off x="1280160" y="3703320"/>
-            <a:ext cx="10332720" cy="548640"/>
+            <a:off x="1280160" y="3648456"/>
+            <a:ext cx="10424160" cy="603504"/>
           </a:xfrm>
           <a:prstGeom prst="rect">
             <a:avLst/>
@@ -1373,7 +1295,7 @@
               <a:buNone/>
             </a:pPr>
             <a:r>
-              <a:rPr lang="en-US" sz="1900" b="1" dirty="0">
+              <a:rPr lang="en-US" sz="2700" b="1" dirty="0">
                 <a:solidFill>
                   <a:srgbClr val="1E2761"/>
                 </a:solidFill>
@@ -1387,7 +1309,7 @@
               <a:buNone/>
             </a:pPr>
             <a:r>
-              <a:rPr lang="en-US" sz="1900" dirty="0">
+              <a:rPr lang="en-US" sz="2700" dirty="0">
                 <a:solidFill>
                   <a:srgbClr val="1E2761"/>
                 </a:solidFill>
@@ -1395,22 +1317,22 @@
                 <a:ea typeface="Calibri" pitchFamily="34" charset="-122"/>
                 <a:cs typeface="Calibri" pitchFamily="34" charset="-120"/>
               </a:rPr>
-              <a:t>mindestens zwei: Gefühl + Wirkung („Ich fühle mich …, wenn Du …“).</a:t>
-            </a:r>
-            <a:endParaRPr lang="en-US" sz="1900" dirty="0"/>
-          </a:p>
-        </p:txBody>
-      </p:sp>
-      <p:sp>
-        <p:nvSpPr>
-          <p:cNvPr id="17" name="Shape 15"/>
+              <a:t>zwei: Gefühl + Wirkung</a:t>
+            </a:r>
+            <a:endParaRPr lang="en-US" sz="2700" dirty="0"/>
+          </a:p>
+        </p:txBody>
+      </p:sp>
+      <p:sp>
+        <p:nvSpPr>
+          <p:cNvPr id="15" name="Shape 13"/>
           <p:cNvSpPr/>
           <p:nvPr/>
         </p:nvSpPr>
         <p:spPr>
           <a:xfrm>
-            <a:off x="548640" y="4389120"/>
-            <a:ext cx="548640" cy="548640"/>
+            <a:off x="457200" y="4416552"/>
+            <a:ext cx="603504" cy="603504"/>
           </a:xfrm>
           <a:prstGeom prst="roundRect">
             <a:avLst>
@@ -1425,14 +1347,14 @@
       </p:sp>
       <p:sp>
         <p:nvSpPr>
-          <p:cNvPr id="18" name="Text 16"/>
+          <p:cNvPr id="16" name="Text 14"/>
           <p:cNvSpPr txBox="1"/>
           <p:nvPr/>
         </p:nvSpPr>
         <p:spPr>
           <a:xfrm>
-            <a:off x="548640" y="4389120"/>
-            <a:ext cx="548640" cy="548640"/>
+            <a:off x="457200" y="4416552"/>
+            <a:ext cx="603504" cy="603504"/>
           </a:xfrm>
           <a:prstGeom prst="rect">
             <a:avLst/>
@@ -1448,7 +1370,7 @@
               <a:buNone/>
             </a:pPr>
             <a:r>
-              <a:rPr lang="en-US" sz="2000" b="1" dirty="0">
+              <a:rPr lang="en-US" sz="2700" b="1" dirty="0">
                 <a:solidFill>
                   <a:srgbClr val="FFFFFF"/>
                 </a:solidFill>
@@ -1458,20 +1380,20 @@
               </a:rPr>
               <a:t>3</a:t>
             </a:r>
-            <a:endParaRPr lang="en-US" sz="2000" dirty="0"/>
-          </a:p>
-        </p:txBody>
-      </p:sp>
-      <p:sp>
-        <p:nvSpPr>
-          <p:cNvPr id="19" name="Text 17"/>
+            <a:endParaRPr lang="en-US" sz="2700" dirty="0"/>
+          </a:p>
+        </p:txBody>
+      </p:sp>
+      <p:sp>
+        <p:nvSpPr>
+          <p:cNvPr id="17" name="Text 15"/>
           <p:cNvSpPr txBox="1"/>
           <p:nvPr/>
         </p:nvSpPr>
         <p:spPr>
           <a:xfrm>
-            <a:off x="1280160" y="4389120"/>
-            <a:ext cx="10332720" cy="548640"/>
+            <a:off x="1280160" y="4416552"/>
+            <a:ext cx="10424160" cy="603504"/>
           </a:xfrm>
           <a:prstGeom prst="rect">
             <a:avLst/>
@@ -1487,7 +1409,7 @@
               <a:buNone/>
             </a:pPr>
             <a:r>
-              <a:rPr lang="en-US" sz="1900" b="1" dirty="0">
+              <a:rPr lang="en-US" sz="2700" b="1" dirty="0">
                 <a:solidFill>
                   <a:srgbClr val="1E2761"/>
                 </a:solidFill>
@@ -1501,7 +1423,7 @@
               <a:buNone/>
             </a:pPr>
             <a:r>
-              <a:rPr lang="en-US" sz="1900" dirty="0">
+              <a:rPr lang="en-US" sz="2700" dirty="0">
                 <a:solidFill>
                   <a:srgbClr val="1E2761"/>
                 </a:solidFill>
@@ -1509,22 +1431,22 @@
                 <a:ea typeface="Calibri" pitchFamily="34" charset="-122"/>
                 <a:cs typeface="Calibri" pitchFamily="34" charset="-120"/>
               </a:rPr>
-              <a:t>eine klare Bitte: Was soll der Vater künftig tun?</a:t>
-            </a:r>
-            <a:endParaRPr lang="en-US" sz="1900" dirty="0"/>
-          </a:p>
-        </p:txBody>
-      </p:sp>
-      <p:sp>
-        <p:nvSpPr>
-          <p:cNvPr id="20" name="Shape 18"/>
+              <a:t>eine klare Bitte</a:t>
+            </a:r>
+            <a:endParaRPr lang="en-US" sz="2700" dirty="0"/>
+          </a:p>
+        </p:txBody>
+      </p:sp>
+      <p:sp>
+        <p:nvSpPr>
+          <p:cNvPr id="18" name="Shape 16"/>
           <p:cNvSpPr/>
           <p:nvPr/>
         </p:nvSpPr>
         <p:spPr>
           <a:xfrm>
-            <a:off x="548640" y="5074920"/>
-            <a:ext cx="548640" cy="548640"/>
+            <a:off x="457200" y="5184648"/>
+            <a:ext cx="603504" cy="603504"/>
           </a:xfrm>
           <a:prstGeom prst="roundRect">
             <a:avLst>
@@ -1539,14 +1461,14 @@
       </p:sp>
       <p:sp>
         <p:nvSpPr>
-          <p:cNvPr id="21" name="Text 19"/>
+          <p:cNvPr id="19" name="Text 17"/>
           <p:cNvSpPr txBox="1"/>
           <p:nvPr/>
         </p:nvSpPr>
         <p:spPr>
           <a:xfrm>
-            <a:off x="548640" y="5074920"/>
-            <a:ext cx="548640" cy="548640"/>
+            <a:off x="457200" y="5184648"/>
+            <a:ext cx="603504" cy="603504"/>
           </a:xfrm>
           <a:prstGeom prst="rect">
             <a:avLst/>
@@ -1562,7 +1484,7 @@
               <a:buNone/>
             </a:pPr>
             <a:r>
-              <a:rPr lang="en-US" sz="2000" b="1" dirty="0">
+              <a:rPr lang="en-US" sz="2700" b="1" dirty="0">
                 <a:solidFill>
                   <a:srgbClr val="FFFFFF"/>
                 </a:solidFill>
@@ -1572,20 +1494,20 @@
               </a:rPr>
               <a:t>4</a:t>
             </a:r>
-            <a:endParaRPr lang="en-US" sz="2000" dirty="0"/>
-          </a:p>
-        </p:txBody>
-      </p:sp>
-      <p:sp>
-        <p:nvSpPr>
-          <p:cNvPr id="22" name="Text 20"/>
+            <a:endParaRPr lang="en-US" sz="2700" dirty="0"/>
+          </a:p>
+        </p:txBody>
+      </p:sp>
+      <p:sp>
+        <p:nvSpPr>
+          <p:cNvPr id="20" name="Text 18"/>
           <p:cNvSpPr txBox="1"/>
           <p:nvPr/>
         </p:nvSpPr>
         <p:spPr>
           <a:xfrm>
-            <a:off x="1280160" y="5074920"/>
-            <a:ext cx="10332720" cy="548640"/>
+            <a:off x="1280160" y="5184648"/>
+            <a:ext cx="10424160" cy="603504"/>
           </a:xfrm>
           <a:prstGeom prst="rect">
             <a:avLst/>
@@ -1601,7 +1523,7 @@
               <a:buNone/>
             </a:pPr>
             <a:r>
-              <a:rPr lang="en-US" sz="1900" b="1" dirty="0">
+              <a:rPr lang="en-US" sz="2700" b="1" dirty="0">
                 <a:solidFill>
                   <a:srgbClr val="1E2761"/>
                 </a:solidFill>
@@ -1615,7 +1537,7 @@
               <a:buNone/>
             </a:pPr>
             <a:r>
-              <a:rPr lang="en-US" sz="1900" dirty="0">
+              <a:rPr lang="en-US" sz="2700" dirty="0">
                 <a:solidFill>
                   <a:srgbClr val="1E2761"/>
                 </a:solidFill>
@@ -1623,22 +1545,22 @@
                 <a:ea typeface="Calibri" pitchFamily="34" charset="-122"/>
                 <a:cs typeface="Calibri" pitchFamily="34" charset="-120"/>
               </a:rPr>
-              <a:t>Kafkas Wünsche aus dem Brief kommen vor (Wort, Hand, Blick).</a:t>
-            </a:r>
-            <a:endParaRPr lang="en-US" sz="1900" dirty="0"/>
-          </a:p>
-        </p:txBody>
-      </p:sp>
-      <p:sp>
-        <p:nvSpPr>
-          <p:cNvPr id="23" name="Shape 21"/>
+              <a:t>Wort, Hand, Blick</a:t>
+            </a:r>
+            <a:endParaRPr lang="en-US" sz="2700" dirty="0"/>
+          </a:p>
+        </p:txBody>
+      </p:sp>
+      <p:sp>
+        <p:nvSpPr>
+          <p:cNvPr id="21" name="Shape 19"/>
           <p:cNvSpPr/>
           <p:nvPr/>
         </p:nvSpPr>
         <p:spPr>
           <a:xfrm>
-            <a:off x="548640" y="5760720"/>
-            <a:ext cx="548640" cy="548640"/>
+            <a:off x="457200" y="5952744"/>
+            <a:ext cx="603504" cy="603504"/>
           </a:xfrm>
           <a:prstGeom prst="roundRect">
             <a:avLst>
@@ -1653,14 +1575,14 @@
       </p:sp>
       <p:sp>
         <p:nvSpPr>
-          <p:cNvPr id="24" name="Text 22"/>
+          <p:cNvPr id="22" name="Text 20"/>
           <p:cNvSpPr txBox="1"/>
           <p:nvPr/>
         </p:nvSpPr>
         <p:spPr>
           <a:xfrm>
-            <a:off x="548640" y="5760720"/>
-            <a:ext cx="548640" cy="548640"/>
+            <a:off x="457200" y="5952744"/>
+            <a:ext cx="603504" cy="603504"/>
           </a:xfrm>
           <a:prstGeom prst="rect">
             <a:avLst/>
@@ -1676,7 +1598,7 @@
               <a:buNone/>
             </a:pPr>
             <a:r>
-              <a:rPr lang="en-US" sz="2000" b="1" dirty="0">
+              <a:rPr lang="en-US" sz="2700" b="1" dirty="0">
                 <a:solidFill>
                   <a:srgbClr val="FFFFFF"/>
                 </a:solidFill>
@@ -1686,20 +1608,20 @@
               </a:rPr>
               <a:t>5</a:t>
             </a:r>
-            <a:endParaRPr lang="en-US" sz="2000" dirty="0"/>
-          </a:p>
-        </p:txBody>
-      </p:sp>
-      <p:sp>
-        <p:nvSpPr>
-          <p:cNvPr id="25" name="Text 23"/>
+            <a:endParaRPr lang="en-US" sz="2700" dirty="0"/>
+          </a:p>
+        </p:txBody>
+      </p:sp>
+      <p:sp>
+        <p:nvSpPr>
+          <p:cNvPr id="23" name="Text 21"/>
           <p:cNvSpPr txBox="1"/>
           <p:nvPr/>
         </p:nvSpPr>
         <p:spPr>
           <a:xfrm>
-            <a:off x="1280160" y="5760720"/>
-            <a:ext cx="10332720" cy="548640"/>
+            <a:off x="1280160" y="5952744"/>
+            <a:ext cx="10424160" cy="603504"/>
           </a:xfrm>
           <a:prstGeom prst="rect">
             <a:avLst/>
@@ -1715,7 +1637,7 @@
               <a:buNone/>
             </a:pPr>
             <a:r>
-              <a:rPr lang="en-US" sz="1900" b="1" dirty="0">
+              <a:rPr lang="en-US" sz="2700" b="1" dirty="0">
                 <a:solidFill>
                   <a:srgbClr val="1E2761"/>
                 </a:solidFill>
@@ -1729,7 +1651,7 @@
               <a:buNone/>
             </a:pPr>
             <a:r>
-              <a:rPr lang="en-US" sz="1900" dirty="0">
+              <a:rPr lang="en-US" sz="2700" dirty="0">
                 <a:solidFill>
                   <a:srgbClr val="1E2761"/>
                 </a:solidFill>
@@ -1737,9 +1659,9 @@
                 <a:ea typeface="Calibri" pitchFamily="34" charset="-122"/>
                 <a:cs typeface="Calibri" pitchFamily="34" charset="-120"/>
               </a:rPr>
-              <a:t>keine Vorwürfe – Kafka sucht keine Schuld.</a:t>
-            </a:r>
-            <a:endParaRPr lang="en-US" sz="1900" dirty="0"/>
+              <a:t>keine Vorwürfe</a:t>
+            </a:r>
+            <a:endParaRPr lang="en-US" sz="2700" dirty="0"/>
           </a:p>
         </p:txBody>
       </p:sp>

</xml_diff>

<commit_message>
Kafka-Appell: Testauswertung + Rechtschreibtraining (Schnipsel mit Sätzen), Kafka nach AVIVA, Arbeitsblatt nach Muster der Mentorin
Co-Authored-By: Claude Opus 5.5 <noreply@anthropic.com>
Claude-Session: https://claude.ai/code/session_01Kzh1oWiqhC6W8oSNq8mKnj
</commit_message>
<xml_diff>
--- a/Deutsch_11/Kafka_Appell/Whiteboard_Rede_Auftrag_Kriterien.pptx
+++ b/Deutsch_11/Kafka_Appell/Whiteboard_Rede_Auftrag_Kriterien.pptx
@@ -942,16 +942,16 @@
         </p:nvSpPr>
         <p:spPr>
           <a:xfrm>
-            <a:off x="9966960" y="137160"/>
-            <a:ext cx="1920240" cy="640080"/>
+            <a:off x="457200" y="1097280"/>
+            <a:ext cx="11247120" cy="1783080"/>
           </a:xfrm>
           <a:prstGeom prst="roundRect">
             <a:avLst>
-              <a:gd name="adj" fmla="val 17143"/>
+              <a:gd name="adj" fmla="val 4103"/>
             </a:avLst>
           </a:prstGeom>
           <a:solidFill>
-            <a:srgbClr val="D9534F"/>
+            <a:srgbClr val="F4F7FD"/>
           </a:solidFill>
           <a:ln/>
         </p:spPr>
@@ -964,8 +964,8 @@
         </p:nvSpPr>
         <p:spPr>
           <a:xfrm>
-            <a:off x="9966960" y="137160"/>
-            <a:ext cx="1920240" cy="640080"/>
+            <a:off x="685800" y="1143000"/>
+            <a:ext cx="10789920" cy="1691640"/>
           </a:xfrm>
           <a:prstGeom prst="rect">
             <a:avLst/>
@@ -977,66 +977,22 @@
           <a:bodyPr wrap="square" lIns="0" tIns="0" rIns="0" bIns="0" rtlCol="0" anchor="ctr"/>
           <a:lstStyle/>
           <a:p>
-            <a:pPr algn="ctr" indent="0" marL="0">
+            <a:pPr indent="0" marL="0">
               <a:buNone/>
             </a:pPr>
             <a:r>
-              <a:rPr lang="en-US" sz="2700" b="1" dirty="0">
+              <a:rPr lang="en-US" sz="2700" dirty="0">
                 <a:solidFill>
-                  <a:srgbClr val="FFFFFF"/>
+                  <a:srgbClr val="1E2761"/>
                 </a:solidFill>
-                <a:latin typeface="Calibri" pitchFamily="34" charset="0"/>
-                <a:ea typeface="Calibri" pitchFamily="34" charset="-122"/>
-                <a:cs typeface="Calibri" pitchFamily="34" charset="-120"/>
+                <a:latin typeface="Cambria" pitchFamily="34" charset="0"/>
+                <a:ea typeface="Cambria" pitchFamily="34" charset="-122"/>
+                <a:cs typeface="Cambria" pitchFamily="34" charset="-120"/>
               </a:rPr>
-              <a:t>12 Min.</a:t>
+              <a:t>Max Brods Brief an Hermann Kafka war erfolgreich: Der Vater ist bereit, seinem Sohn zuzuhören.</a:t>
             </a:r>
             <a:endParaRPr lang="en-US" sz="2700" dirty="0"/>
           </a:p>
-        </p:txBody>
-      </p:sp>
-      <p:sp>
-        <p:nvSpPr>
-          <p:cNvPr id="6" name="Shape 4"/>
-          <p:cNvSpPr/>
-          <p:nvPr/>
-        </p:nvSpPr>
-        <p:spPr>
-          <a:xfrm>
-            <a:off x="457200" y="1097280"/>
-            <a:ext cx="11247120" cy="1600200"/>
-          </a:xfrm>
-          <a:prstGeom prst="roundRect">
-            <a:avLst>
-              <a:gd name="adj" fmla="val 4571"/>
-            </a:avLst>
-          </a:prstGeom>
-          <a:solidFill>
-            <a:srgbClr val="F4F7FD"/>
-          </a:solidFill>
-          <a:ln/>
-        </p:spPr>
-      </p:sp>
-      <p:sp>
-        <p:nvSpPr>
-          <p:cNvPr id="7" name="Text 5"/>
-          <p:cNvSpPr txBox="1"/>
-          <p:nvPr/>
-        </p:nvSpPr>
-        <p:spPr>
-          <a:xfrm>
-            <a:off x="685800" y="1143000"/>
-            <a:ext cx="10789920" cy="1005840"/>
-          </a:xfrm>
-          <a:prstGeom prst="rect">
-            <a:avLst/>
-          </a:prstGeom>
-          <a:noFill/>
-          <a:ln/>
-        </p:spPr>
-        <p:txBody>
-          <a:bodyPr wrap="square" lIns="0" tIns="0" rIns="0" bIns="0" rtlCol="0" anchor="ctr"/>
-          <a:lstStyle/>
           <a:p>
             <a:pPr indent="0" marL="0">
               <a:buNone/>
@@ -1050,7 +1006,7 @@
                 <a:ea typeface="Cambria" pitchFamily="34" charset="-122"/>
                 <a:cs typeface="Cambria" pitchFamily="34" charset="-120"/>
               </a:rPr>
-              <a:t>Max Brods Brief hat gewirkt: Der Vater hört zu. Schreibe die Rede, die Franz jetzt an ihn hält.</a:t>
+              <a:t>Schreibe als Franz eine Rede an den Vater, in der du an ihn appellierst.</a:t>
             </a:r>
             <a:endParaRPr lang="en-US" sz="2700" dirty="0"/>
           </a:p>
@@ -1058,14 +1014,14 @@
       </p:sp>
       <p:sp>
         <p:nvSpPr>
-          <p:cNvPr id="8" name="Text 6"/>
+          <p:cNvPr id="6" name="Text 4"/>
           <p:cNvSpPr txBox="1"/>
           <p:nvPr/>
         </p:nvSpPr>
         <p:spPr>
           <a:xfrm>
-            <a:off x="685800" y="2148840"/>
-            <a:ext cx="10789920" cy="457200"/>
+            <a:off x="457200" y="2971800"/>
+            <a:ext cx="11247120" cy="457200"/>
           </a:xfrm>
           <a:prstGeom prst="rect">
             <a:avLst/>
@@ -1089,7 +1045,7 @@
                 <a:ea typeface="Calibri" pitchFamily="34" charset="-122"/>
                 <a:cs typeface="Calibri" pitchFamily="34" charset="-120"/>
               </a:rPr>
-              <a:t>6–8 Sätze · allein · in den Hefter</a:t>
+              <a:t>ca. 100–150 Wörter · allein · in den Hefter</a:t>
             </a:r>
             <a:endParaRPr lang="en-US" sz="2700" dirty="0"/>
           </a:p>
@@ -1097,14 +1053,14 @@
       </p:sp>
       <p:sp>
         <p:nvSpPr>
-          <p:cNvPr id="9" name="Shape 7"/>
+          <p:cNvPr id="7" name="Shape 5"/>
           <p:cNvSpPr/>
           <p:nvPr/>
         </p:nvSpPr>
         <p:spPr>
           <a:xfrm>
-            <a:off x="457200" y="2880360"/>
-            <a:ext cx="603504" cy="603504"/>
+            <a:off x="457200" y="3547872"/>
+            <a:ext cx="530352" cy="530352"/>
           </a:xfrm>
           <a:prstGeom prst="roundRect">
             <a:avLst>
@@ -1119,14 +1075,14 @@
       </p:sp>
       <p:sp>
         <p:nvSpPr>
-          <p:cNvPr id="10" name="Text 8"/>
+          <p:cNvPr id="8" name="Text 6"/>
           <p:cNvSpPr txBox="1"/>
           <p:nvPr/>
         </p:nvSpPr>
         <p:spPr>
           <a:xfrm>
-            <a:off x="457200" y="2880360"/>
-            <a:ext cx="603504" cy="603504"/>
+            <a:off x="457200" y="3547872"/>
+            <a:ext cx="530352" cy="530352"/>
           </a:xfrm>
           <a:prstGeom prst="rect">
             <a:avLst/>
@@ -1158,14 +1114,14 @@
       </p:sp>
       <p:sp>
         <p:nvSpPr>
-          <p:cNvPr id="11" name="Text 9"/>
+          <p:cNvPr id="9" name="Text 7"/>
           <p:cNvSpPr txBox="1"/>
           <p:nvPr/>
         </p:nvSpPr>
         <p:spPr>
           <a:xfrm>
-            <a:off x="1280160" y="2880360"/>
-            <a:ext cx="10424160" cy="603504"/>
+            <a:off x="1188720" y="3520440"/>
+            <a:ext cx="10515600" cy="585216"/>
           </a:xfrm>
           <a:prstGeom prst="rect">
             <a:avLst/>
@@ -1211,14 +1167,14 @@
       </p:sp>
       <p:sp>
         <p:nvSpPr>
-          <p:cNvPr id="12" name="Shape 10"/>
+          <p:cNvPr id="10" name="Shape 8"/>
           <p:cNvSpPr/>
           <p:nvPr/>
         </p:nvSpPr>
         <p:spPr>
           <a:xfrm>
-            <a:off x="457200" y="3648456"/>
-            <a:ext cx="603504" cy="603504"/>
+            <a:off x="457200" y="4187952"/>
+            <a:ext cx="530352" cy="530352"/>
           </a:xfrm>
           <a:prstGeom prst="roundRect">
             <a:avLst>
@@ -1233,14 +1189,14 @@
       </p:sp>
       <p:sp>
         <p:nvSpPr>
-          <p:cNvPr id="13" name="Text 11"/>
+          <p:cNvPr id="11" name="Text 9"/>
           <p:cNvSpPr txBox="1"/>
           <p:nvPr/>
         </p:nvSpPr>
         <p:spPr>
           <a:xfrm>
-            <a:off x="457200" y="3648456"/>
-            <a:ext cx="603504" cy="603504"/>
+            <a:off x="457200" y="4187952"/>
+            <a:ext cx="530352" cy="530352"/>
           </a:xfrm>
           <a:prstGeom prst="rect">
             <a:avLst/>
@@ -1272,14 +1228,14 @@
       </p:sp>
       <p:sp>
         <p:nvSpPr>
-          <p:cNvPr id="14" name="Text 12"/>
+          <p:cNvPr id="12" name="Text 10"/>
           <p:cNvSpPr txBox="1"/>
           <p:nvPr/>
         </p:nvSpPr>
         <p:spPr>
           <a:xfrm>
-            <a:off x="1280160" y="3648456"/>
-            <a:ext cx="10424160" cy="603504"/>
+            <a:off x="1188720" y="4160520"/>
+            <a:ext cx="10515600" cy="585216"/>
           </a:xfrm>
           <a:prstGeom prst="rect">
             <a:avLst/>
@@ -1317,7 +1273,7 @@
                 <a:ea typeface="Calibri" pitchFamily="34" charset="-122"/>
                 <a:cs typeface="Calibri" pitchFamily="34" charset="-120"/>
               </a:rPr>
-              <a:t>zwei: Gefühl + Wirkung</a:t>
+              <a:t>mindestens zwei: Gefühl + Wirkung</a:t>
             </a:r>
             <a:endParaRPr lang="en-US" sz="2700" dirty="0"/>
           </a:p>
@@ -1325,14 +1281,14 @@
       </p:sp>
       <p:sp>
         <p:nvSpPr>
-          <p:cNvPr id="15" name="Shape 13"/>
+          <p:cNvPr id="13" name="Shape 11"/>
           <p:cNvSpPr/>
           <p:nvPr/>
         </p:nvSpPr>
         <p:spPr>
           <a:xfrm>
-            <a:off x="457200" y="4416552"/>
-            <a:ext cx="603504" cy="603504"/>
+            <a:off x="457200" y="4828032"/>
+            <a:ext cx="530352" cy="530352"/>
           </a:xfrm>
           <a:prstGeom prst="roundRect">
             <a:avLst>
@@ -1347,14 +1303,14 @@
       </p:sp>
       <p:sp>
         <p:nvSpPr>
-          <p:cNvPr id="16" name="Text 14"/>
+          <p:cNvPr id="14" name="Text 12"/>
           <p:cNvSpPr txBox="1"/>
           <p:nvPr/>
         </p:nvSpPr>
         <p:spPr>
           <a:xfrm>
-            <a:off x="457200" y="4416552"/>
-            <a:ext cx="603504" cy="603504"/>
+            <a:off x="457200" y="4828032"/>
+            <a:ext cx="530352" cy="530352"/>
           </a:xfrm>
           <a:prstGeom prst="rect">
             <a:avLst/>
@@ -1386,14 +1342,14 @@
       </p:sp>
       <p:sp>
         <p:nvSpPr>
-          <p:cNvPr id="17" name="Text 15"/>
+          <p:cNvPr id="15" name="Text 13"/>
           <p:cNvSpPr txBox="1"/>
           <p:nvPr/>
         </p:nvSpPr>
         <p:spPr>
           <a:xfrm>
-            <a:off x="1280160" y="4416552"/>
-            <a:ext cx="10424160" cy="603504"/>
+            <a:off x="1188720" y="4800600"/>
+            <a:ext cx="10515600" cy="585216"/>
           </a:xfrm>
           <a:prstGeom prst="rect">
             <a:avLst/>
@@ -1431,7 +1387,7 @@
                 <a:ea typeface="Calibri" pitchFamily="34" charset="-122"/>
                 <a:cs typeface="Calibri" pitchFamily="34" charset="-120"/>
               </a:rPr>
-              <a:t>eine klare Bitte</a:t>
+              <a:t>mindestens eine klare Bitte</a:t>
             </a:r>
             <a:endParaRPr lang="en-US" sz="2700" dirty="0"/>
           </a:p>
@@ -1439,14 +1395,14 @@
       </p:sp>
       <p:sp>
         <p:nvSpPr>
-          <p:cNvPr id="18" name="Shape 16"/>
+          <p:cNvPr id="16" name="Shape 14"/>
           <p:cNvSpPr/>
           <p:nvPr/>
         </p:nvSpPr>
         <p:spPr>
           <a:xfrm>
-            <a:off x="457200" y="5184648"/>
-            <a:ext cx="603504" cy="603504"/>
+            <a:off x="457200" y="5468112"/>
+            <a:ext cx="530352" cy="530352"/>
           </a:xfrm>
           <a:prstGeom prst="roundRect">
             <a:avLst>
@@ -1461,14 +1417,14 @@
       </p:sp>
       <p:sp>
         <p:nvSpPr>
-          <p:cNvPr id="19" name="Text 17"/>
+          <p:cNvPr id="17" name="Text 15"/>
           <p:cNvSpPr txBox="1"/>
           <p:nvPr/>
         </p:nvSpPr>
         <p:spPr>
           <a:xfrm>
-            <a:off x="457200" y="5184648"/>
-            <a:ext cx="603504" cy="603504"/>
+            <a:off x="457200" y="5468112"/>
+            <a:ext cx="530352" cy="530352"/>
           </a:xfrm>
           <a:prstGeom prst="rect">
             <a:avLst/>
@@ -1500,14 +1456,14 @@
       </p:sp>
       <p:sp>
         <p:nvSpPr>
-          <p:cNvPr id="20" name="Text 18"/>
+          <p:cNvPr id="18" name="Text 16"/>
           <p:cNvSpPr txBox="1"/>
           <p:nvPr/>
         </p:nvSpPr>
         <p:spPr>
           <a:xfrm>
-            <a:off x="1280160" y="5184648"/>
-            <a:ext cx="10424160" cy="603504"/>
+            <a:off x="1188720" y="5440680"/>
+            <a:ext cx="10515600" cy="585216"/>
           </a:xfrm>
           <a:prstGeom prst="rect">
             <a:avLst/>
@@ -1545,7 +1501,7 @@
                 <a:ea typeface="Calibri" pitchFamily="34" charset="-122"/>
                 <a:cs typeface="Calibri" pitchFamily="34" charset="-120"/>
               </a:rPr>
-              <a:t>Wort, Hand, Blick</a:t>
+              <a:t>Kafkas Wünsche: Wort, Hand, Blick</a:t>
             </a:r>
             <a:endParaRPr lang="en-US" sz="2700" dirty="0"/>
           </a:p>
@@ -1553,14 +1509,14 @@
       </p:sp>
       <p:sp>
         <p:nvSpPr>
-          <p:cNvPr id="21" name="Shape 19"/>
+          <p:cNvPr id="19" name="Shape 17"/>
           <p:cNvSpPr/>
           <p:nvPr/>
         </p:nvSpPr>
         <p:spPr>
           <a:xfrm>
-            <a:off x="457200" y="5952744"/>
-            <a:ext cx="603504" cy="603504"/>
+            <a:off x="457200" y="6108192"/>
+            <a:ext cx="530352" cy="530352"/>
           </a:xfrm>
           <a:prstGeom prst="roundRect">
             <a:avLst>
@@ -1575,14 +1531,14 @@
       </p:sp>
       <p:sp>
         <p:nvSpPr>
-          <p:cNvPr id="22" name="Text 20"/>
+          <p:cNvPr id="20" name="Text 18"/>
           <p:cNvSpPr txBox="1"/>
           <p:nvPr/>
         </p:nvSpPr>
         <p:spPr>
           <a:xfrm>
-            <a:off x="457200" y="5952744"/>
-            <a:ext cx="603504" cy="603504"/>
+            <a:off x="457200" y="6108192"/>
+            <a:ext cx="530352" cy="530352"/>
           </a:xfrm>
           <a:prstGeom prst="rect">
             <a:avLst/>
@@ -1614,14 +1570,14 @@
       </p:sp>
       <p:sp>
         <p:nvSpPr>
-          <p:cNvPr id="23" name="Text 21"/>
+          <p:cNvPr id="21" name="Text 19"/>
           <p:cNvSpPr txBox="1"/>
           <p:nvPr/>
         </p:nvSpPr>
         <p:spPr>
           <a:xfrm>
-            <a:off x="1280160" y="5952744"/>
-            <a:ext cx="10424160" cy="603504"/>
+            <a:off x="1188720" y="6080760"/>
+            <a:ext cx="10515600" cy="585216"/>
           </a:xfrm>
           <a:prstGeom prst="rect">
             <a:avLst/>
@@ -1645,7 +1601,7 @@
                 <a:ea typeface="Calibri" pitchFamily="34" charset="-122"/>
                 <a:cs typeface="Calibri" pitchFamily="34" charset="-120"/>
               </a:rPr>
-              <a:t>Respektvoller Ton:  </a:t>
+              <a:t>Ton:  </a:t>
             </a:r>
             <a:pPr indent="0" marL="0">
               <a:buNone/>
@@ -1659,7 +1615,7 @@
                 <a:ea typeface="Calibri" pitchFamily="34" charset="-122"/>
                 <a:cs typeface="Calibri" pitchFamily="34" charset="-120"/>
               </a:rPr>
-              <a:t>keine Vorwürfe</a:t>
+              <a:t>ehrlich, mutig, respektvoll – keine Vorwürfe</a:t>
             </a:r>
             <a:endParaRPr lang="en-US" sz="2700" dirty="0"/>
           </a:p>

</xml_diff>